<commit_message>
Update Instructions for Paper Review on EasyChair(Reviewer)[UV2026][20260605].pptx
</commit_message>
<xml_diff>
--- a/Instructions/Instructions for Paper Review on EasyChair(Reviewer)[UV2026][20260605].pptx
+++ b/Instructions/Instructions for Paper Review on EasyChair(Reviewer)[UV2026][20260605].pptx
@@ -5,38 +5,38 @@
     <p:sldMasterId id="2147483648" r:id="rId1"/>
   </p:sldMasterIdLst>
   <p:notesMasterIdLst>
-    <p:notesMasterId r:id="rId4"/>
+    <p:notesMasterId r:id="rId28"/>
   </p:notesMasterIdLst>
   <p:handoutMasterIdLst>
-    <p:handoutMasterId r:id="rId30"/>
+    <p:handoutMasterId r:id="rId29"/>
   </p:handoutMasterIdLst>
   <p:sldIdLst>
-    <p:sldId id="256" r:id="rId3"/>
-    <p:sldId id="257" r:id="rId5"/>
-    <p:sldId id="285" r:id="rId6"/>
-    <p:sldId id="286" r:id="rId7"/>
-    <p:sldId id="287" r:id="rId8"/>
-    <p:sldId id="288" r:id="rId9"/>
-    <p:sldId id="289" r:id="rId10"/>
-    <p:sldId id="290" r:id="rId11"/>
-    <p:sldId id="298" r:id="rId12"/>
-    <p:sldId id="279" r:id="rId13"/>
-    <p:sldId id="264" r:id="rId14"/>
-    <p:sldId id="265" r:id="rId15"/>
-    <p:sldId id="266" r:id="rId16"/>
-    <p:sldId id="267" r:id="rId17"/>
-    <p:sldId id="268" r:id="rId18"/>
-    <p:sldId id="269" r:id="rId19"/>
-    <p:sldId id="270" r:id="rId20"/>
-    <p:sldId id="271" r:id="rId21"/>
-    <p:sldId id="272" r:id="rId22"/>
-    <p:sldId id="273" r:id="rId23"/>
-    <p:sldId id="280" r:id="rId24"/>
-    <p:sldId id="281" r:id="rId25"/>
-    <p:sldId id="282" r:id="rId26"/>
-    <p:sldId id="292" r:id="rId27"/>
-    <p:sldId id="284" r:id="rId28"/>
-    <p:sldId id="294" r:id="rId29"/>
+    <p:sldId id="256" r:id="rId2"/>
+    <p:sldId id="257" r:id="rId3"/>
+    <p:sldId id="285" r:id="rId4"/>
+    <p:sldId id="286" r:id="rId5"/>
+    <p:sldId id="287" r:id="rId6"/>
+    <p:sldId id="288" r:id="rId7"/>
+    <p:sldId id="289" r:id="rId8"/>
+    <p:sldId id="290" r:id="rId9"/>
+    <p:sldId id="298" r:id="rId10"/>
+    <p:sldId id="279" r:id="rId11"/>
+    <p:sldId id="264" r:id="rId12"/>
+    <p:sldId id="265" r:id="rId13"/>
+    <p:sldId id="266" r:id="rId14"/>
+    <p:sldId id="267" r:id="rId15"/>
+    <p:sldId id="268" r:id="rId16"/>
+    <p:sldId id="269" r:id="rId17"/>
+    <p:sldId id="270" r:id="rId18"/>
+    <p:sldId id="271" r:id="rId19"/>
+    <p:sldId id="272" r:id="rId20"/>
+    <p:sldId id="273" r:id="rId21"/>
+    <p:sldId id="280" r:id="rId22"/>
+    <p:sldId id="281" r:id="rId23"/>
+    <p:sldId id="282" r:id="rId24"/>
+    <p:sldId id="292" r:id="rId25"/>
+    <p:sldId id="284" r:id="rId26"/>
+    <p:sldId id="294" r:id="rId27"/>
   </p:sldIdLst>
   <p:sldSz cx="9144000" cy="5143500" type="screen16x9"/>
   <p:notesSz cx="6858000" cy="9144000"/>
@@ -370,6 +370,7 @@
           <a:p>
             <a:fld id="{696C064A-D61B-4B21-B757-51A9B82445B8}" type="datetimeFigureOut">
               <a:rPr lang="en-US" smtClean="0"/>
+              <a:t>6/6/26</a:t>
             </a:fld>
             <a:endParaRPr lang="en-US"/>
           </a:p>
@@ -435,12 +436,18 @@
           <a:p>
             <a:fld id="{50305E07-67EA-4042-A3F6-853A8AD8D209}" type="slidenum">
               <a:rPr lang="en-US" smtClean="0"/>
+              <a:t>‹#›</a:t>
             </a:fld>
             <a:endParaRPr lang="en-US"/>
           </a:p>
         </p:txBody>
       </p:sp>
     </p:spTree>
+    <p:extLst>
+      <p:ext uri="{BB962C8B-B14F-4D97-AF65-F5344CB8AC3E}">
+        <p14:creationId xmlns:p14="http://schemas.microsoft.com/office/powerpoint/2010/main" val="1"/>
+      </p:ext>
+    </p:extLst>
   </p:cSld>
   <p:clrMap bg1="lt1" tx1="dk1" bg2="lt2" tx2="dk2" accent1="accent1" accent2="accent2" accent3="accent3" accent4="accent4" accent5="accent5" accent6="accent6" hlink="hlink" folHlink="folHlink"/>
 </p:handoutMaster>
@@ -647,7 +654,9 @@
               <a:defRPr sz="1100"/>
             </a:lvl9pPr>
           </a:lstStyle>
-          <a:p/>
+          <a:p>
+            <a:endParaRPr/>
+          </a:p>
         </p:txBody>
       </p:sp>
     </p:spTree>
@@ -886,7 +895,7 @@
 </file>
 
 <file path=ppt/notesSlides/notesSlide1.xml><?xml version="1.0" encoding="utf-8"?>
-<p:notes xmlns:a="http://schemas.openxmlformats.org/drawingml/2006/main" xmlns:r="http://schemas.openxmlformats.org/officeDocument/2006/relationships" xmlns:p="http://schemas.openxmlformats.org/presentationml/2006/main" showMasterPhAnim="0" showMasterSp="0">
+<p:notes xmlns:a="http://schemas.openxmlformats.org/drawingml/2006/main" xmlns:r="http://schemas.openxmlformats.org/officeDocument/2006/relationships" xmlns:p="http://schemas.openxmlformats.org/presentationml/2006/main" showMasterSp="0" showMasterPhAnim="0">
   <p:cSld>
     <p:spTree>
       <p:nvGrpSpPr>
@@ -977,6 +986,7 @@
               </a:spcAft>
               <a:buNone/>
             </a:pPr>
+            <a:endParaRPr/>
           </a:p>
         </p:txBody>
       </p:sp>
@@ -989,7 +999,7 @@
 </file>
 
 <file path=ppt/notesSlides/notesSlide10.xml><?xml version="1.0" encoding="utf-8"?>
-<p:notes xmlns:a="http://schemas.openxmlformats.org/drawingml/2006/main" xmlns:r="http://schemas.openxmlformats.org/officeDocument/2006/relationships" xmlns:p="http://schemas.openxmlformats.org/presentationml/2006/main" showMasterPhAnim="0" showMasterSp="0">
+<p:notes xmlns:a="http://schemas.openxmlformats.org/drawingml/2006/main" xmlns:r="http://schemas.openxmlformats.org/officeDocument/2006/relationships" xmlns:p="http://schemas.openxmlformats.org/presentationml/2006/main" showMasterSp="0" showMasterPhAnim="0">
   <p:cSld>
     <p:spTree>
       <p:nvGrpSpPr>
@@ -1093,7 +1103,7 @@
 </file>
 
 <file path=ppt/notesSlides/notesSlide11.xml><?xml version="1.0" encoding="utf-8"?>
-<p:notes xmlns:a="http://schemas.openxmlformats.org/drawingml/2006/main" xmlns:r="http://schemas.openxmlformats.org/officeDocument/2006/relationships" xmlns:p="http://schemas.openxmlformats.org/presentationml/2006/main" showMasterPhAnim="0" showMasterSp="0">
+<p:notes xmlns:a="http://schemas.openxmlformats.org/drawingml/2006/main" xmlns:r="http://schemas.openxmlformats.org/officeDocument/2006/relationships" xmlns:p="http://schemas.openxmlformats.org/presentationml/2006/main" showMasterSp="0" showMasterPhAnim="0">
   <p:cSld>
     <p:spTree>
       <p:nvGrpSpPr>
@@ -1184,6 +1194,7 @@
               </a:spcAft>
               <a:buNone/>
             </a:pPr>
+            <a:endParaRPr/>
           </a:p>
         </p:txBody>
       </p:sp>
@@ -1196,7 +1207,7 @@
 </file>
 
 <file path=ppt/notesSlides/notesSlide12.xml><?xml version="1.0" encoding="utf-8"?>
-<p:notes xmlns:a="http://schemas.openxmlformats.org/drawingml/2006/main" xmlns:r="http://schemas.openxmlformats.org/officeDocument/2006/relationships" xmlns:p="http://schemas.openxmlformats.org/presentationml/2006/main" showMasterPhAnim="0" showMasterSp="0">
+<p:notes xmlns:a="http://schemas.openxmlformats.org/drawingml/2006/main" xmlns:r="http://schemas.openxmlformats.org/officeDocument/2006/relationships" xmlns:p="http://schemas.openxmlformats.org/presentationml/2006/main" showMasterSp="0" showMasterPhAnim="0">
   <p:cSld>
     <p:spTree>
       <p:nvGrpSpPr>
@@ -1287,6 +1298,7 @@
               </a:spcAft>
               <a:buNone/>
             </a:pPr>
+            <a:endParaRPr/>
           </a:p>
         </p:txBody>
       </p:sp>
@@ -1299,7 +1311,7 @@
 </file>
 
 <file path=ppt/notesSlides/notesSlide13.xml><?xml version="1.0" encoding="utf-8"?>
-<p:notes xmlns:a="http://schemas.openxmlformats.org/drawingml/2006/main" xmlns:r="http://schemas.openxmlformats.org/officeDocument/2006/relationships" xmlns:p="http://schemas.openxmlformats.org/presentationml/2006/main" showMasterPhAnim="0" showMasterSp="0">
+<p:notes xmlns:a="http://schemas.openxmlformats.org/drawingml/2006/main" xmlns:r="http://schemas.openxmlformats.org/officeDocument/2006/relationships" xmlns:p="http://schemas.openxmlformats.org/presentationml/2006/main" showMasterSp="0" showMasterPhAnim="0">
   <p:cSld>
     <p:spTree>
       <p:nvGrpSpPr>
@@ -1390,6 +1402,7 @@
               </a:spcAft>
               <a:buNone/>
             </a:pPr>
+            <a:endParaRPr/>
           </a:p>
         </p:txBody>
       </p:sp>
@@ -1402,7 +1415,7 @@
 </file>
 
 <file path=ppt/notesSlides/notesSlide14.xml><?xml version="1.0" encoding="utf-8"?>
-<p:notes xmlns:a="http://schemas.openxmlformats.org/drawingml/2006/main" xmlns:r="http://schemas.openxmlformats.org/officeDocument/2006/relationships" xmlns:p="http://schemas.openxmlformats.org/presentationml/2006/main" showMasterPhAnim="0" showMasterSp="0">
+<p:notes xmlns:a="http://schemas.openxmlformats.org/drawingml/2006/main" xmlns:r="http://schemas.openxmlformats.org/officeDocument/2006/relationships" xmlns:p="http://schemas.openxmlformats.org/presentationml/2006/main" showMasterSp="0" showMasterPhAnim="0">
   <p:cSld>
     <p:spTree>
       <p:nvGrpSpPr>
@@ -1493,6 +1506,7 @@
               </a:spcAft>
               <a:buNone/>
             </a:pPr>
+            <a:endParaRPr/>
           </a:p>
         </p:txBody>
       </p:sp>
@@ -1505,7 +1519,7 @@
 </file>
 
 <file path=ppt/notesSlides/notesSlide15.xml><?xml version="1.0" encoding="utf-8"?>
-<p:notes xmlns:a="http://schemas.openxmlformats.org/drawingml/2006/main" xmlns:r="http://schemas.openxmlformats.org/officeDocument/2006/relationships" xmlns:p="http://schemas.openxmlformats.org/presentationml/2006/main" showMasterPhAnim="0" showMasterSp="0">
+<p:notes xmlns:a="http://schemas.openxmlformats.org/drawingml/2006/main" xmlns:r="http://schemas.openxmlformats.org/officeDocument/2006/relationships" xmlns:p="http://schemas.openxmlformats.org/presentationml/2006/main" showMasterSp="0" showMasterPhAnim="0">
   <p:cSld>
     <p:spTree>
       <p:nvGrpSpPr>
@@ -1596,6 +1610,7 @@
               </a:spcAft>
               <a:buNone/>
             </a:pPr>
+            <a:endParaRPr/>
           </a:p>
         </p:txBody>
       </p:sp>
@@ -1608,7 +1623,7 @@
 </file>
 
 <file path=ppt/notesSlides/notesSlide16.xml><?xml version="1.0" encoding="utf-8"?>
-<p:notes xmlns:a="http://schemas.openxmlformats.org/drawingml/2006/main" xmlns:r="http://schemas.openxmlformats.org/officeDocument/2006/relationships" xmlns:p="http://schemas.openxmlformats.org/presentationml/2006/main" showMasterPhAnim="0" showMasterSp="0">
+<p:notes xmlns:a="http://schemas.openxmlformats.org/drawingml/2006/main" xmlns:r="http://schemas.openxmlformats.org/officeDocument/2006/relationships" xmlns:p="http://schemas.openxmlformats.org/presentationml/2006/main" showMasterSp="0" showMasterPhAnim="0">
   <p:cSld>
     <p:spTree>
       <p:nvGrpSpPr>
@@ -1699,6 +1714,7 @@
               </a:spcAft>
               <a:buNone/>
             </a:pPr>
+            <a:endParaRPr/>
           </a:p>
         </p:txBody>
       </p:sp>
@@ -1711,7 +1727,7 @@
 </file>
 
 <file path=ppt/notesSlides/notesSlide17.xml><?xml version="1.0" encoding="utf-8"?>
-<p:notes xmlns:a="http://schemas.openxmlformats.org/drawingml/2006/main" xmlns:r="http://schemas.openxmlformats.org/officeDocument/2006/relationships" xmlns:p="http://schemas.openxmlformats.org/presentationml/2006/main" showMasterPhAnim="0" showMasterSp="0">
+<p:notes xmlns:a="http://schemas.openxmlformats.org/drawingml/2006/main" xmlns:r="http://schemas.openxmlformats.org/officeDocument/2006/relationships" xmlns:p="http://schemas.openxmlformats.org/presentationml/2006/main" showMasterSp="0" showMasterPhAnim="0">
   <p:cSld>
     <p:spTree>
       <p:nvGrpSpPr>
@@ -1802,6 +1818,7 @@
               </a:spcAft>
               <a:buNone/>
             </a:pPr>
+            <a:endParaRPr/>
           </a:p>
         </p:txBody>
       </p:sp>
@@ -1814,7 +1831,7 @@
 </file>
 
 <file path=ppt/notesSlides/notesSlide18.xml><?xml version="1.0" encoding="utf-8"?>
-<p:notes xmlns:a="http://schemas.openxmlformats.org/drawingml/2006/main" xmlns:r="http://schemas.openxmlformats.org/officeDocument/2006/relationships" xmlns:p="http://schemas.openxmlformats.org/presentationml/2006/main" showMasterPhAnim="0" showMasterSp="0">
+<p:notes xmlns:a="http://schemas.openxmlformats.org/drawingml/2006/main" xmlns:r="http://schemas.openxmlformats.org/officeDocument/2006/relationships" xmlns:p="http://schemas.openxmlformats.org/presentationml/2006/main" showMasterSp="0" showMasterPhAnim="0">
   <p:cSld>
     <p:spTree>
       <p:nvGrpSpPr>
@@ -1905,6 +1922,7 @@
               </a:spcAft>
               <a:buNone/>
             </a:pPr>
+            <a:endParaRPr/>
           </a:p>
         </p:txBody>
       </p:sp>
@@ -1917,7 +1935,7 @@
 </file>
 
 <file path=ppt/notesSlides/notesSlide19.xml><?xml version="1.0" encoding="utf-8"?>
-<p:notes xmlns:a="http://schemas.openxmlformats.org/drawingml/2006/main" xmlns:r="http://schemas.openxmlformats.org/officeDocument/2006/relationships" xmlns:p="http://schemas.openxmlformats.org/presentationml/2006/main" showMasterPhAnim="0" showMasterSp="0">
+<p:notes xmlns:a="http://schemas.openxmlformats.org/drawingml/2006/main" xmlns:r="http://schemas.openxmlformats.org/officeDocument/2006/relationships" xmlns:p="http://schemas.openxmlformats.org/presentationml/2006/main" showMasterSp="0" showMasterPhAnim="0">
   <p:cSld>
     <p:spTree>
       <p:nvGrpSpPr>
@@ -2008,6 +2026,7 @@
               </a:spcAft>
               <a:buNone/>
             </a:pPr>
+            <a:endParaRPr/>
           </a:p>
         </p:txBody>
       </p:sp>
@@ -2020,7 +2039,7 @@
 </file>
 
 <file path=ppt/notesSlides/notesSlide2.xml><?xml version="1.0" encoding="utf-8"?>
-<p:notes xmlns:a="http://schemas.openxmlformats.org/drawingml/2006/main" xmlns:r="http://schemas.openxmlformats.org/officeDocument/2006/relationships" xmlns:p="http://schemas.openxmlformats.org/presentationml/2006/main" showMasterPhAnim="0" showMasterSp="0">
+<p:notes xmlns:a="http://schemas.openxmlformats.org/drawingml/2006/main" xmlns:r="http://schemas.openxmlformats.org/officeDocument/2006/relationships" xmlns:p="http://schemas.openxmlformats.org/presentationml/2006/main" showMasterSp="0" showMasterPhAnim="0">
   <p:cSld>
     <p:spTree>
       <p:nvGrpSpPr>
@@ -2111,6 +2130,7 @@
               </a:spcAft>
               <a:buNone/>
             </a:pPr>
+            <a:endParaRPr/>
           </a:p>
         </p:txBody>
       </p:sp>
@@ -2123,7 +2143,7 @@
 </file>
 
 <file path=ppt/notesSlides/notesSlide20.xml><?xml version="1.0" encoding="utf-8"?>
-<p:notes xmlns:a="http://schemas.openxmlformats.org/drawingml/2006/main" xmlns:r="http://schemas.openxmlformats.org/officeDocument/2006/relationships" xmlns:p="http://schemas.openxmlformats.org/presentationml/2006/main" showMasterPhAnim="0" showMasterSp="0">
+<p:notes xmlns:a="http://schemas.openxmlformats.org/drawingml/2006/main" xmlns:r="http://schemas.openxmlformats.org/officeDocument/2006/relationships" xmlns:p="http://schemas.openxmlformats.org/presentationml/2006/main" showMasterSp="0" showMasterPhAnim="0">
   <p:cSld>
     <p:spTree>
       <p:nvGrpSpPr>
@@ -2214,6 +2234,7 @@
               </a:spcAft>
               <a:buNone/>
             </a:pPr>
+            <a:endParaRPr/>
           </a:p>
         </p:txBody>
       </p:sp>
@@ -2226,7 +2247,7 @@
 </file>
 
 <file path=ppt/notesSlides/notesSlide21.xml><?xml version="1.0" encoding="utf-8"?>
-<p:notes xmlns:a="http://schemas.openxmlformats.org/drawingml/2006/main" xmlns:r="http://schemas.openxmlformats.org/officeDocument/2006/relationships" xmlns:p="http://schemas.openxmlformats.org/presentationml/2006/main" showMasterPhAnim="0" showMasterSp="0">
+<p:notes xmlns:a="http://schemas.openxmlformats.org/drawingml/2006/main" xmlns:r="http://schemas.openxmlformats.org/officeDocument/2006/relationships" xmlns:p="http://schemas.openxmlformats.org/presentationml/2006/main" showMasterSp="0" showMasterPhAnim="0">
   <p:cSld>
     <p:spTree>
       <p:nvGrpSpPr>
@@ -2317,6 +2338,7 @@
               </a:spcAft>
               <a:buNone/>
             </a:pPr>
+            <a:endParaRPr/>
           </a:p>
         </p:txBody>
       </p:sp>
@@ -2329,7 +2351,7 @@
 </file>
 
 <file path=ppt/notesSlides/notesSlide22.xml><?xml version="1.0" encoding="utf-8"?>
-<p:notes xmlns:a="http://schemas.openxmlformats.org/drawingml/2006/main" xmlns:r="http://schemas.openxmlformats.org/officeDocument/2006/relationships" xmlns:p="http://schemas.openxmlformats.org/presentationml/2006/main" showMasterPhAnim="0" showMasterSp="0">
+<p:notes xmlns:a="http://schemas.openxmlformats.org/drawingml/2006/main" xmlns:r="http://schemas.openxmlformats.org/officeDocument/2006/relationships" xmlns:p="http://schemas.openxmlformats.org/presentationml/2006/main" showMasterSp="0" showMasterPhAnim="0">
   <p:cSld>
     <p:spTree>
       <p:nvGrpSpPr>
@@ -2420,6 +2442,7 @@
               </a:spcAft>
               <a:buNone/>
             </a:pPr>
+            <a:endParaRPr/>
           </a:p>
         </p:txBody>
       </p:sp>
@@ -2432,7 +2455,7 @@
 </file>
 
 <file path=ppt/notesSlides/notesSlide23.xml><?xml version="1.0" encoding="utf-8"?>
-<p:notes xmlns:a="http://schemas.openxmlformats.org/drawingml/2006/main" xmlns:r="http://schemas.openxmlformats.org/officeDocument/2006/relationships" xmlns:p="http://schemas.openxmlformats.org/presentationml/2006/main" showMasterPhAnim="0" showMasterSp="0">
+<p:notes xmlns:a="http://schemas.openxmlformats.org/drawingml/2006/main" xmlns:r="http://schemas.openxmlformats.org/officeDocument/2006/relationships" xmlns:p="http://schemas.openxmlformats.org/presentationml/2006/main" showMasterSp="0" showMasterPhAnim="0">
   <p:cSld>
     <p:spTree>
       <p:nvGrpSpPr>
@@ -2523,6 +2546,7 @@
               </a:spcAft>
               <a:buNone/>
             </a:pPr>
+            <a:endParaRPr/>
           </a:p>
         </p:txBody>
       </p:sp>
@@ -2535,7 +2559,7 @@
 </file>
 
 <file path=ppt/notesSlides/notesSlide24.xml><?xml version="1.0" encoding="utf-8"?>
-<p:notes xmlns:a="http://schemas.openxmlformats.org/drawingml/2006/main" xmlns:r="http://schemas.openxmlformats.org/officeDocument/2006/relationships" xmlns:p="http://schemas.openxmlformats.org/presentationml/2006/main" showMasterPhAnim="0" showMasterSp="0">
+<p:notes xmlns:a="http://schemas.openxmlformats.org/drawingml/2006/main" xmlns:r="http://schemas.openxmlformats.org/officeDocument/2006/relationships" xmlns:p="http://schemas.openxmlformats.org/presentationml/2006/main" showMasterSp="0" showMasterPhAnim="0">
   <p:cSld>
     <p:spTree>
       <p:nvGrpSpPr>
@@ -2626,6 +2650,7 @@
               </a:spcAft>
               <a:buNone/>
             </a:pPr>
+            <a:endParaRPr/>
           </a:p>
         </p:txBody>
       </p:sp>
@@ -2638,7 +2663,7 @@
 </file>
 
 <file path=ppt/notesSlides/notesSlide25.xml><?xml version="1.0" encoding="utf-8"?>
-<p:notes xmlns:a="http://schemas.openxmlformats.org/drawingml/2006/main" xmlns:r="http://schemas.openxmlformats.org/officeDocument/2006/relationships" xmlns:p="http://schemas.openxmlformats.org/presentationml/2006/main" showMasterPhAnim="0" showMasterSp="0">
+<p:notes xmlns:a="http://schemas.openxmlformats.org/drawingml/2006/main" xmlns:r="http://schemas.openxmlformats.org/officeDocument/2006/relationships" xmlns:p="http://schemas.openxmlformats.org/presentationml/2006/main" showMasterSp="0" showMasterPhAnim="0">
   <p:cSld>
     <p:spTree>
       <p:nvGrpSpPr>
@@ -2729,6 +2754,7 @@
               </a:spcAft>
               <a:buNone/>
             </a:pPr>
+            <a:endParaRPr/>
           </a:p>
         </p:txBody>
       </p:sp>
@@ -2741,7 +2767,7 @@
 </file>
 
 <file path=ppt/notesSlides/notesSlide3.xml><?xml version="1.0" encoding="utf-8"?>
-<p:notes xmlns:a="http://schemas.openxmlformats.org/drawingml/2006/main" xmlns:r="http://schemas.openxmlformats.org/officeDocument/2006/relationships" xmlns:p="http://schemas.openxmlformats.org/presentationml/2006/main" showMasterPhAnim="0" showMasterSp="0">
+<p:notes xmlns:a="http://schemas.openxmlformats.org/drawingml/2006/main" xmlns:r="http://schemas.openxmlformats.org/officeDocument/2006/relationships" xmlns:p="http://schemas.openxmlformats.org/presentationml/2006/main" showMasterSp="0" showMasterPhAnim="0">
   <p:cSld>
     <p:spTree>
       <p:nvGrpSpPr>
@@ -2832,6 +2858,7 @@
               </a:spcAft>
               <a:buNone/>
             </a:pPr>
+            <a:endParaRPr/>
           </a:p>
         </p:txBody>
       </p:sp>
@@ -2844,7 +2871,7 @@
 </file>
 
 <file path=ppt/notesSlides/notesSlide4.xml><?xml version="1.0" encoding="utf-8"?>
-<p:notes xmlns:a="http://schemas.openxmlformats.org/drawingml/2006/main" xmlns:r="http://schemas.openxmlformats.org/officeDocument/2006/relationships" xmlns:p="http://schemas.openxmlformats.org/presentationml/2006/main" showMasterPhAnim="0" showMasterSp="0">
+<p:notes xmlns:a="http://schemas.openxmlformats.org/drawingml/2006/main" xmlns:r="http://schemas.openxmlformats.org/officeDocument/2006/relationships" xmlns:p="http://schemas.openxmlformats.org/presentationml/2006/main" showMasterSp="0" showMasterPhAnim="0">
   <p:cSld>
     <p:spTree>
       <p:nvGrpSpPr>
@@ -2935,6 +2962,7 @@
               </a:spcAft>
               <a:buNone/>
             </a:pPr>
+            <a:endParaRPr/>
           </a:p>
         </p:txBody>
       </p:sp>
@@ -2947,7 +2975,7 @@
 </file>
 
 <file path=ppt/notesSlides/notesSlide5.xml><?xml version="1.0" encoding="utf-8"?>
-<p:notes xmlns:a="http://schemas.openxmlformats.org/drawingml/2006/main" xmlns:r="http://schemas.openxmlformats.org/officeDocument/2006/relationships" xmlns:p="http://schemas.openxmlformats.org/presentationml/2006/main" showMasterPhAnim="0" showMasterSp="0">
+<p:notes xmlns:a="http://schemas.openxmlformats.org/drawingml/2006/main" xmlns:r="http://schemas.openxmlformats.org/officeDocument/2006/relationships" xmlns:p="http://schemas.openxmlformats.org/presentationml/2006/main" showMasterSp="0" showMasterPhAnim="0">
   <p:cSld>
     <p:spTree>
       <p:nvGrpSpPr>
@@ -3038,6 +3066,7 @@
               </a:spcAft>
               <a:buNone/>
             </a:pPr>
+            <a:endParaRPr/>
           </a:p>
         </p:txBody>
       </p:sp>
@@ -3050,7 +3079,7 @@
 </file>
 
 <file path=ppt/notesSlides/notesSlide6.xml><?xml version="1.0" encoding="utf-8"?>
-<p:notes xmlns:a="http://schemas.openxmlformats.org/drawingml/2006/main" xmlns:r="http://schemas.openxmlformats.org/officeDocument/2006/relationships" xmlns:p="http://schemas.openxmlformats.org/presentationml/2006/main" showMasterPhAnim="0" showMasterSp="0">
+<p:notes xmlns:a="http://schemas.openxmlformats.org/drawingml/2006/main" xmlns:r="http://schemas.openxmlformats.org/officeDocument/2006/relationships" xmlns:p="http://schemas.openxmlformats.org/presentationml/2006/main" showMasterSp="0" showMasterPhAnim="0">
   <p:cSld>
     <p:spTree>
       <p:nvGrpSpPr>
@@ -3141,6 +3170,7 @@
               </a:spcAft>
               <a:buNone/>
             </a:pPr>
+            <a:endParaRPr/>
           </a:p>
         </p:txBody>
       </p:sp>
@@ -3153,7 +3183,7 @@
 </file>
 
 <file path=ppt/notesSlides/notesSlide7.xml><?xml version="1.0" encoding="utf-8"?>
-<p:notes xmlns:a="http://schemas.openxmlformats.org/drawingml/2006/main" xmlns:r="http://schemas.openxmlformats.org/officeDocument/2006/relationships" xmlns:p="http://schemas.openxmlformats.org/presentationml/2006/main" showMasterPhAnim="0" showMasterSp="0">
+<p:notes xmlns:a="http://schemas.openxmlformats.org/drawingml/2006/main" xmlns:r="http://schemas.openxmlformats.org/officeDocument/2006/relationships" xmlns:p="http://schemas.openxmlformats.org/presentationml/2006/main" showMasterSp="0" showMasterPhAnim="0">
   <p:cSld>
     <p:spTree>
       <p:nvGrpSpPr>
@@ -3244,6 +3274,7 @@
               </a:spcAft>
               <a:buNone/>
             </a:pPr>
+            <a:endParaRPr/>
           </a:p>
         </p:txBody>
       </p:sp>
@@ -3256,7 +3287,7 @@
 </file>
 
 <file path=ppt/notesSlides/notesSlide8.xml><?xml version="1.0" encoding="utf-8"?>
-<p:notes xmlns:a="http://schemas.openxmlformats.org/drawingml/2006/main" xmlns:r="http://schemas.openxmlformats.org/officeDocument/2006/relationships" xmlns:p="http://schemas.openxmlformats.org/presentationml/2006/main" showMasterPhAnim="0" showMasterSp="0">
+<p:notes xmlns:a="http://schemas.openxmlformats.org/drawingml/2006/main" xmlns:r="http://schemas.openxmlformats.org/officeDocument/2006/relationships" xmlns:p="http://schemas.openxmlformats.org/presentationml/2006/main" showMasterSp="0" showMasterPhAnim="0">
   <p:cSld>
     <p:spTree>
       <p:nvGrpSpPr>
@@ -3347,6 +3378,7 @@
               </a:spcAft>
               <a:buNone/>
             </a:pPr>
+            <a:endParaRPr/>
           </a:p>
         </p:txBody>
       </p:sp>
@@ -3359,7 +3391,7 @@
 </file>
 
 <file path=ppt/notesSlides/notesSlide9.xml><?xml version="1.0" encoding="utf-8"?>
-<p:notes xmlns:a="http://schemas.openxmlformats.org/drawingml/2006/main" xmlns:r="http://schemas.openxmlformats.org/officeDocument/2006/relationships" xmlns:p="http://schemas.openxmlformats.org/presentationml/2006/main" showMasterPhAnim="0" showMasterSp="0">
+<p:notes xmlns:a="http://schemas.openxmlformats.org/drawingml/2006/main" xmlns:r="http://schemas.openxmlformats.org/officeDocument/2006/relationships" xmlns:p="http://schemas.openxmlformats.org/presentationml/2006/main" showMasterSp="0" showMasterPhAnim="0">
   <p:cSld>
     <p:spTree>
       <p:nvGrpSpPr>
@@ -3463,7 +3495,7 @@
 </file>
 
 <file path=ppt/slideLayouts/slideLayout1.xml><?xml version="1.0" encoding="utf-8"?>
-<p:sldLayout xmlns:a="http://schemas.openxmlformats.org/drawingml/2006/main" xmlns:r="http://schemas.openxmlformats.org/officeDocument/2006/relationships" xmlns:p="http://schemas.openxmlformats.org/presentationml/2006/main" type="title" matchingName="Title slide">
+<p:sldLayout xmlns:a="http://schemas.openxmlformats.org/drawingml/2006/main" xmlns:r="http://schemas.openxmlformats.org/officeDocument/2006/relationships" xmlns:p="http://schemas.openxmlformats.org/presentationml/2006/main" matchingName="Title slide" type="title">
   <p:cSld name="TITLE">
     <p:spTree>
       <p:nvGrpSpPr>
@@ -3603,7 +3635,9 @@
               <a:defRPr sz="5200"/>
             </a:lvl9pPr>
           </a:lstStyle>
-          <a:p/>
+          <a:p>
+            <a:endParaRPr/>
+          </a:p>
         </p:txBody>
       </p:sp>
       <p:sp>
@@ -3757,7 +3791,9 @@
               <a:defRPr sz="2800"/>
             </a:lvl9pPr>
           </a:lstStyle>
-          <a:p/>
+          <a:p>
+            <a:endParaRPr/>
+          </a:p>
         </p:txBody>
       </p:sp>
       <p:sp>
@@ -3833,6 +3869,7 @@
             </a:pPr>
             <a:fld id="{00000000-1234-1234-1234-123412341234}" type="slidenum">
               <a:rPr lang="en-GB"/>
+              <a:t>‹#›</a:t>
             </a:fld>
             <a:endParaRPr lang="en-GB"/>
           </a:p>
@@ -4118,7 +4155,9 @@
               <a:defRPr/>
             </a:lvl9pPr>
           </a:lstStyle>
-          <a:p/>
+          <a:p>
+            <a:endParaRPr/>
+          </a:p>
         </p:txBody>
       </p:sp>
       <p:sp>
@@ -4194,6 +4233,7 @@
             </a:pPr>
             <a:fld id="{00000000-1234-1234-1234-123412341234}" type="slidenum">
               <a:rPr lang="en-GB"/>
+              <a:t>‹#›</a:t>
             </a:fld>
             <a:endParaRPr lang="en-GB"/>
           </a:p>
@@ -4208,7 +4248,7 @@
 </file>
 
 <file path=ppt/slideLayouts/slideLayout11.xml><?xml version="1.0" encoding="utf-8"?>
-<p:sldLayout xmlns:a="http://schemas.openxmlformats.org/drawingml/2006/main" xmlns:r="http://schemas.openxmlformats.org/officeDocument/2006/relationships" xmlns:p="http://schemas.openxmlformats.org/presentationml/2006/main" type="blank" matchingName="Blank">
+<p:sldLayout xmlns:a="http://schemas.openxmlformats.org/drawingml/2006/main" xmlns:r="http://schemas.openxmlformats.org/officeDocument/2006/relationships" xmlns:p="http://schemas.openxmlformats.org/presentationml/2006/main" matchingName="Blank" type="blank">
   <p:cSld name="BLANK">
     <p:spTree>
       <p:nvGrpSpPr>
@@ -4297,6 +4337,7 @@
             </a:pPr>
             <a:fld id="{00000000-1234-1234-1234-123412341234}" type="slidenum">
               <a:rPr lang="en-GB"/>
+              <a:t>‹#›</a:t>
             </a:fld>
             <a:endParaRPr lang="en-GB"/>
           </a:p>
@@ -4311,7 +4352,7 @@
 </file>
 
 <file path=ppt/slideLayouts/slideLayout2.xml><?xml version="1.0" encoding="utf-8"?>
-<p:sldLayout xmlns:a="http://schemas.openxmlformats.org/drawingml/2006/main" xmlns:r="http://schemas.openxmlformats.org/officeDocument/2006/relationships" xmlns:p="http://schemas.openxmlformats.org/presentationml/2006/main" type="secHead" matchingName="Section header">
+<p:sldLayout xmlns:a="http://schemas.openxmlformats.org/drawingml/2006/main" xmlns:r="http://schemas.openxmlformats.org/officeDocument/2006/relationships" xmlns:p="http://schemas.openxmlformats.org/presentationml/2006/main" matchingName="Section header" type="secHead">
   <p:cSld name="SECTION_HEADER">
     <p:spTree>
       <p:nvGrpSpPr>
@@ -4451,7 +4492,9 @@
               <a:defRPr sz="3600"/>
             </a:lvl9pPr>
           </a:lstStyle>
-          <a:p/>
+          <a:p>
+            <a:endParaRPr/>
+          </a:p>
         </p:txBody>
       </p:sp>
       <p:sp>
@@ -4527,6 +4570,7 @@
             </a:pPr>
             <a:fld id="{00000000-1234-1234-1234-123412341234}" type="slidenum">
               <a:rPr lang="en-GB"/>
+              <a:t>‹#›</a:t>
             </a:fld>
             <a:endParaRPr lang="en-GB"/>
           </a:p>
@@ -4541,7 +4585,7 @@
 </file>
 
 <file path=ppt/slideLayouts/slideLayout3.xml><?xml version="1.0" encoding="utf-8"?>
-<p:sldLayout xmlns:a="http://schemas.openxmlformats.org/drawingml/2006/main" xmlns:r="http://schemas.openxmlformats.org/officeDocument/2006/relationships" xmlns:p="http://schemas.openxmlformats.org/presentationml/2006/main" type="tx" matchingName="Title and body">
+<p:sldLayout xmlns:a="http://schemas.openxmlformats.org/drawingml/2006/main" xmlns:r="http://schemas.openxmlformats.org/officeDocument/2006/relationships" xmlns:p="http://schemas.openxmlformats.org/presentationml/2006/main" matchingName="Title and body" type="tx">
   <p:cSld name="TITLE_AND_BODY">
     <p:spTree>
       <p:nvGrpSpPr>
@@ -4681,7 +4725,9 @@
               <a:defRPr/>
             </a:lvl9pPr>
           </a:lstStyle>
-          <a:p/>
+          <a:p>
+            <a:endParaRPr/>
+          </a:p>
         </p:txBody>
       </p:sp>
       <p:sp>
@@ -4808,7 +4854,9 @@
               <a:defRPr/>
             </a:lvl9pPr>
           </a:lstStyle>
-          <a:p/>
+          <a:p>
+            <a:endParaRPr/>
+          </a:p>
         </p:txBody>
       </p:sp>
       <p:sp>
@@ -4884,6 +4932,7 @@
             </a:pPr>
             <a:fld id="{00000000-1234-1234-1234-123412341234}" type="slidenum">
               <a:rPr lang="en-GB"/>
+              <a:t>‹#›</a:t>
             </a:fld>
             <a:endParaRPr lang="en-GB"/>
           </a:p>
@@ -4898,7 +4947,7 @@
 </file>
 
 <file path=ppt/slideLayouts/slideLayout4.xml><?xml version="1.0" encoding="utf-8"?>
-<p:sldLayout xmlns:a="http://schemas.openxmlformats.org/drawingml/2006/main" xmlns:r="http://schemas.openxmlformats.org/officeDocument/2006/relationships" xmlns:p="http://schemas.openxmlformats.org/presentationml/2006/main" type="twoColTx" matchingName="Title and two columns">
+<p:sldLayout xmlns:a="http://schemas.openxmlformats.org/drawingml/2006/main" xmlns:r="http://schemas.openxmlformats.org/officeDocument/2006/relationships" xmlns:p="http://schemas.openxmlformats.org/presentationml/2006/main" matchingName="Title and two columns" type="twoColTx">
   <p:cSld name="TITLE_AND_TWO_COLUMNS">
     <p:spTree>
       <p:nvGrpSpPr>
@@ -5038,7 +5087,9 @@
               <a:defRPr/>
             </a:lvl9pPr>
           </a:lstStyle>
-          <a:p/>
+          <a:p>
+            <a:endParaRPr/>
+          </a:p>
         </p:txBody>
       </p:sp>
       <p:sp>
@@ -5165,7 +5216,9 @@
               <a:defRPr sz="1200"/>
             </a:lvl9pPr>
           </a:lstStyle>
-          <a:p/>
+          <a:p>
+            <a:endParaRPr/>
+          </a:p>
         </p:txBody>
       </p:sp>
       <p:sp>
@@ -5292,7 +5345,9 @@
               <a:defRPr sz="1200"/>
             </a:lvl9pPr>
           </a:lstStyle>
-          <a:p/>
+          <a:p>
+            <a:endParaRPr/>
+          </a:p>
         </p:txBody>
       </p:sp>
       <p:sp>
@@ -5368,6 +5423,7 @@
             </a:pPr>
             <a:fld id="{00000000-1234-1234-1234-123412341234}" type="slidenum">
               <a:rPr lang="en-GB"/>
+              <a:t>‹#›</a:t>
             </a:fld>
             <a:endParaRPr lang="en-GB"/>
           </a:p>
@@ -5382,7 +5438,7 @@
 </file>
 
 <file path=ppt/slideLayouts/slideLayout5.xml><?xml version="1.0" encoding="utf-8"?>
-<p:sldLayout xmlns:a="http://schemas.openxmlformats.org/drawingml/2006/main" xmlns:r="http://schemas.openxmlformats.org/officeDocument/2006/relationships" xmlns:p="http://schemas.openxmlformats.org/presentationml/2006/main" type="titleOnly" matchingName="Title only">
+<p:sldLayout xmlns:a="http://schemas.openxmlformats.org/drawingml/2006/main" xmlns:r="http://schemas.openxmlformats.org/officeDocument/2006/relationships" xmlns:p="http://schemas.openxmlformats.org/presentationml/2006/main" matchingName="Title only" type="titleOnly">
   <p:cSld name="TITLE_ONLY">
     <p:spTree>
       <p:nvGrpSpPr>
@@ -5522,7 +5578,9 @@
               <a:defRPr/>
             </a:lvl9pPr>
           </a:lstStyle>
-          <a:p/>
+          <a:p>
+            <a:endParaRPr/>
+          </a:p>
         </p:txBody>
       </p:sp>
       <p:sp>
@@ -5598,6 +5656,7 @@
             </a:pPr>
             <a:fld id="{00000000-1234-1234-1234-123412341234}" type="slidenum">
               <a:rPr lang="en-GB"/>
+              <a:t>‹#›</a:t>
             </a:fld>
             <a:endParaRPr lang="en-GB"/>
           </a:p>
@@ -5752,7 +5811,9 @@
               <a:defRPr sz="2400"/>
             </a:lvl9pPr>
           </a:lstStyle>
-          <a:p/>
+          <a:p>
+            <a:endParaRPr/>
+          </a:p>
         </p:txBody>
       </p:sp>
       <p:sp>
@@ -5879,7 +5940,9 @@
               <a:defRPr sz="1200"/>
             </a:lvl9pPr>
           </a:lstStyle>
-          <a:p/>
+          <a:p>
+            <a:endParaRPr/>
+          </a:p>
         </p:txBody>
       </p:sp>
       <p:sp>
@@ -5955,6 +6018,7 @@
             </a:pPr>
             <a:fld id="{00000000-1234-1234-1234-123412341234}" type="slidenum">
               <a:rPr lang="en-GB"/>
+              <a:t>‹#›</a:t>
             </a:fld>
             <a:endParaRPr lang="en-GB"/>
           </a:p>
@@ -6109,7 +6173,9 @@
               <a:defRPr sz="4800"/>
             </a:lvl9pPr>
           </a:lstStyle>
-          <a:p/>
+          <a:p>
+            <a:endParaRPr/>
+          </a:p>
         </p:txBody>
       </p:sp>
       <p:sp>
@@ -6185,6 +6251,7 @@
             </a:pPr>
             <a:fld id="{00000000-1234-1234-1234-123412341234}" type="slidenum">
               <a:rPr lang="en-GB"/>
+              <a:t>‹#›</a:t>
             </a:fld>
             <a:endParaRPr lang="en-GB"/>
           </a:p>
@@ -6251,6 +6318,7 @@
               </a:spcAft>
               <a:buNone/>
             </a:pPr>
+            <a:endParaRPr/>
           </a:p>
         </p:txBody>
       </p:sp>
@@ -6378,7 +6446,9 @@
               <a:defRPr sz="4200"/>
             </a:lvl9pPr>
           </a:lstStyle>
-          <a:p/>
+          <a:p>
+            <a:endParaRPr/>
+          </a:p>
         </p:txBody>
       </p:sp>
       <p:sp>
@@ -6532,7 +6602,9 @@
               <a:defRPr sz="2100"/>
             </a:lvl9pPr>
           </a:lstStyle>
-          <a:p/>
+          <a:p>
+            <a:endParaRPr/>
+          </a:p>
         </p:txBody>
       </p:sp>
       <p:sp>
@@ -6659,7 +6731,9 @@
               <a:defRPr/>
             </a:lvl9pPr>
           </a:lstStyle>
-          <a:p/>
+          <a:p>
+            <a:endParaRPr/>
+          </a:p>
         </p:txBody>
       </p:sp>
       <p:sp>
@@ -6735,6 +6809,7 @@
             </a:pPr>
             <a:fld id="{00000000-1234-1234-1234-123412341234}" type="slidenum">
               <a:rPr lang="en-GB"/>
+              <a:t>‹#›</a:t>
             </a:fld>
             <a:endParaRPr lang="en-GB"/>
           </a:p>
@@ -6804,7 +6879,9 @@
               <a:defRPr/>
             </a:lvl1pPr>
           </a:lstStyle>
-          <a:p/>
+          <a:p>
+            <a:endParaRPr/>
+          </a:p>
         </p:txBody>
       </p:sp>
       <p:sp>
@@ -6880,6 +6957,7 @@
             </a:pPr>
             <a:fld id="{00000000-1234-1234-1234-123412341234}" type="slidenum">
               <a:rPr lang="en-GB"/>
+              <a:t>‹#›</a:t>
             </a:fld>
             <a:endParaRPr lang="en-GB"/>
           </a:p>
@@ -7109,7 +7187,9 @@
               </a:defRPr>
             </a:lvl9pPr>
           </a:lstStyle>
-          <a:p/>
+          <a:p>
+            <a:endParaRPr/>
+          </a:p>
         </p:txBody>
       </p:sp>
       <p:sp>
@@ -7330,7 +7410,9 @@
               </a:defRPr>
             </a:lvl9pPr>
           </a:lstStyle>
-          <a:p/>
+          <a:p>
+            <a:endParaRPr/>
+          </a:p>
         </p:txBody>
       </p:sp>
       <p:sp>
@@ -7446,6 +7528,7 @@
             </a:pPr>
             <a:fld id="{00000000-1234-1234-1234-123412341234}" type="slidenum">
               <a:rPr lang="en-GB"/>
+              <a:t>‹#›</a:t>
             </a:fld>
             <a:endParaRPr lang="en-GB"/>
           </a:p>
@@ -8396,7 +8479,7 @@
             <p:nvPr/>
           </p:nvPicPr>
           <p:blipFill>
-            <a:blip r:embed="rId1"/>
+            <a:blip r:embed="rId3"/>
             <a:stretch>
               <a:fillRect/>
             </a:stretch>
@@ -8425,10 +8508,10 @@
             <p:nvPr/>
           </p:nvPicPr>
           <p:blipFill>
-            <a:blip r:embed="rId2">
+            <a:blip r:embed="rId4">
               <a:extLst>
                 <a:ext uri="{96DAC541-7B7A-43D3-8B79-37D633B846F1}">
-                  <asvg:svgBlip xmlns:asvg="http://schemas.microsoft.com/office/drawing/2016/SVG/main" r:embed="rId3"/>
+                  <asvg:svgBlip xmlns:asvg="http://schemas.microsoft.com/office/drawing/2016/SVG/main" r:embed="rId5"/>
                 </a:ext>
               </a:extLst>
             </a:blip>
@@ -8455,10 +8538,10 @@
             <p:nvPr/>
           </p:nvPicPr>
           <p:blipFill>
-            <a:blip r:embed="rId4">
+            <a:blip r:embed="rId6">
               <a:extLst>
                 <a:ext uri="{96DAC541-7B7A-43D3-8B79-37D633B846F1}">
-                  <asvg:svgBlip xmlns:asvg="http://schemas.microsoft.com/office/drawing/2016/SVG/main" r:embed="rId5"/>
+                  <asvg:svgBlip xmlns:asvg="http://schemas.microsoft.com/office/drawing/2016/SVG/main" r:embed="rId7"/>
                 </a:ext>
               </a:extLst>
             </a:blip>
@@ -8796,13 +8879,6 @@
               </a:rPr>
               <a:t> Account-8</a:t>
             </a:r>
-            <a:endParaRPr lang="en-US" altLang="zh-CN" sz="3110" b="1" dirty="0">
-              <a:solidFill>
-                <a:srgbClr val="980000"/>
-              </a:solidFill>
-              <a:latin typeface="Times New Roman" panose="02020603050405020304" pitchFamily="18" charset="0"/>
-              <a:cs typeface="Times New Roman" panose="02020603050405020304" pitchFamily="18" charset="0"/>
-            </a:endParaRPr>
           </a:p>
         </p:txBody>
       </p:sp>
@@ -8928,10 +9004,6 @@
               </a:rPr>
               <a:t>Reviewers may access assigned papers and submit reviews through one of the following methods:</a:t>
             </a:r>
-            <a:endParaRPr lang="en-US" sz="2000" dirty="0">
-              <a:latin typeface="Times New Roman" panose="02020603050405020304" pitchFamily="18" charset="0"/>
-              <a:cs typeface="Times New Roman" panose="02020603050405020304" pitchFamily="18" charset="0"/>
-            </a:endParaRPr>
           </a:p>
           <a:p>
             <a:pPr lvl="0" indent="-457200" algn="l" rtl="0">
@@ -8982,13 +9054,6 @@
               </a:rPr>
               <a:t>(recommended)</a:t>
             </a:r>
-            <a:endParaRPr lang="en-US" sz="2000" b="1" dirty="0">
-              <a:solidFill>
-                <a:srgbClr val="00B050"/>
-              </a:solidFill>
-              <a:latin typeface="Times New Roman" panose="02020603050405020304" pitchFamily="18" charset="0"/>
-              <a:cs typeface="Times New Roman" panose="02020603050405020304" pitchFamily="18" charset="0"/>
-            </a:endParaRPr>
           </a:p>
           <a:p>
             <a:pPr lvl="0" indent="-457200" algn="l" rtl="0">
@@ -9015,10 +9080,6 @@
               </a:rPr>
               <a:t>Use a chair-assisted review workflow, only if arranged by your session chair</a:t>
             </a:r>
-            <a:endParaRPr lang="en-US" sz="2000" dirty="0">
-              <a:latin typeface="Times New Roman" panose="02020603050405020304" pitchFamily="18" charset="0"/>
-              <a:cs typeface="Times New Roman" panose="02020603050405020304" pitchFamily="18" charset="0"/>
-            </a:endParaRPr>
           </a:p>
           <a:p>
             <a:pPr lvl="0" indent="-457200" algn="l" rtl="0">
@@ -9255,13 +9316,6 @@
               </a:rPr>
               <a:t> account. Once the assignment has been completed, please follow the steps below to review the paper(s).</a:t>
             </a:r>
-            <a:endParaRPr lang="en-US" sz="2000" dirty="0">
-              <a:solidFill>
-                <a:schemeClr val="dk1"/>
-              </a:solidFill>
-              <a:latin typeface="Times New Roman" panose="02020603050405020304" pitchFamily="18" charset="0"/>
-              <a:cs typeface="Times New Roman" panose="02020603050405020304" pitchFamily="18" charset="0"/>
-            </a:endParaRPr>
           </a:p>
         </p:txBody>
       </p:sp>
@@ -9377,13 +9431,6 @@
               </a:rPr>
               <a:t>” to access your assigned review request(s).</a:t>
             </a:r>
-            <a:endParaRPr lang="en-US" dirty="0">
-              <a:solidFill>
-                <a:schemeClr val="dk1"/>
-              </a:solidFill>
-              <a:latin typeface="Times New Roman" panose="02020603050405020304" pitchFamily="18" charset="0"/>
-              <a:cs typeface="Times New Roman" panose="02020603050405020304" pitchFamily="18" charset="0"/>
-            </a:endParaRPr>
           </a:p>
           <a:p>
             <a:pPr marL="0" marR="0" lvl="0" indent="0" algn="l" rtl="0">
@@ -9435,7 +9482,7 @@
                 </a:solidFill>
                 <a:latin typeface="Times New Roman" panose="02020603050405020304" pitchFamily="18" charset="0"/>
                 <a:cs typeface="Times New Roman" panose="02020603050405020304" pitchFamily="18" charset="0"/>
-                <a:hlinkClick r:id="rId1"/>
+                <a:hlinkClick r:id="rId3"/>
               </a:rPr>
               <a:t>uv.conf.committee@universal-village.org</a:t>
             </a:r>
@@ -9449,13 +9496,6 @@
               </a:rPr>
               <a:t>  for assistance.</a:t>
             </a:r>
-            <a:endParaRPr lang="en-US" dirty="0">
-              <a:solidFill>
-                <a:schemeClr val="dk1"/>
-              </a:solidFill>
-              <a:latin typeface="Times New Roman" panose="02020603050405020304" pitchFamily="18" charset="0"/>
-              <a:cs typeface="Times New Roman" panose="02020603050405020304" pitchFamily="18" charset="0"/>
-            </a:endParaRPr>
           </a:p>
           <a:p>
             <a:pPr marL="0" lvl="0" indent="0" algn="l" rtl="0">
@@ -9560,7 +9600,7 @@
           <p:nvPr/>
         </p:nvPicPr>
         <p:blipFill>
-          <a:blip r:embed="rId2"/>
+          <a:blip r:embed="rId4"/>
           <a:srcRect l="1" r="1190"/>
           <a:stretch>
             <a:fillRect/>
@@ -9638,7 +9678,7 @@
           <p:nvPr/>
         </p:nvPicPr>
         <p:blipFill>
-          <a:blip r:embed="rId3"/>
+          <a:blip r:embed="rId5"/>
           <a:stretch>
             <a:fillRect/>
           </a:stretch>
@@ -9727,13 +9767,6 @@
               </a:rPr>
               <a:t>b) Click the view icon           to open the assigned review request.</a:t>
             </a:r>
-            <a:endParaRPr lang="en-US" sz="2000" dirty="0">
-              <a:solidFill>
-                <a:schemeClr val="dk1"/>
-              </a:solidFill>
-              <a:latin typeface="Times New Roman" panose="02020603050405020304" pitchFamily="18" charset="0"/>
-              <a:cs typeface="Times New Roman" panose="02020603050405020304" pitchFamily="18" charset="0"/>
-            </a:endParaRPr>
           </a:p>
         </p:txBody>
       </p:sp>
@@ -9744,7 +9777,7 @@
           <p:nvPr/>
         </p:nvPicPr>
         <p:blipFill>
-          <a:blip r:embed="rId1"/>
+          <a:blip r:embed="rId3"/>
           <a:srcRect b="20451"/>
           <a:stretch>
             <a:fillRect/>
@@ -9852,7 +9885,7 @@
           <p:nvPr/>
         </p:nvPicPr>
         <p:blipFill>
-          <a:blip r:embed="rId2"/>
+          <a:blip r:embed="rId4"/>
           <a:stretch>
             <a:fillRect/>
           </a:stretch>
@@ -9975,13 +10008,6 @@
               </a:rPr>
               <a:t> sent by your session chair. </a:t>
             </a:r>
-            <a:endParaRPr lang="en-US" sz="2000" dirty="0">
-              <a:solidFill>
-                <a:schemeClr val="tx1"/>
-              </a:solidFill>
-              <a:latin typeface="Times New Roman" panose="02020603050405020304" pitchFamily="18" charset="0"/>
-              <a:cs typeface="Times New Roman" panose="02020603050405020304" pitchFamily="18" charset="0"/>
-            </a:endParaRPr>
           </a:p>
           <a:p>
             <a:pPr marL="133350" lvl="0" indent="0" algn="l" rtl="0">
@@ -10123,7 +10149,7 @@
           <p:nvPr/>
         </p:nvPicPr>
         <p:blipFill>
-          <a:blip r:embed="rId1"/>
+          <a:blip r:embed="rId3"/>
           <a:srcRect r="953"/>
           <a:stretch>
             <a:fillRect/>
@@ -10319,7 +10345,7 @@
           <p:nvPr/>
         </p:nvPicPr>
         <p:blipFill>
-          <a:blip r:embed="rId1"/>
+          <a:blip r:embed="rId3"/>
           <a:srcRect r="37669"/>
           <a:stretch>
             <a:fillRect/>
@@ -10349,7 +10375,7 @@
           <p:nvPr/>
         </p:nvPicPr>
         <p:blipFill>
-          <a:blip r:embed="rId2"/>
+          <a:blip r:embed="rId4"/>
           <a:stretch>
             <a:fillRect/>
           </a:stretch>
@@ -10733,13 +10759,6 @@
               </a:rPr>
               <a:t>e) Download the assigned paper by clicking the download icon        .</a:t>
             </a:r>
-            <a:endParaRPr lang="en-US" sz="2000" dirty="0">
-              <a:solidFill>
-                <a:schemeClr val="tx1"/>
-              </a:solidFill>
-              <a:latin typeface="Times New Roman" panose="02020603050405020304" pitchFamily="18" charset="0"/>
-              <a:cs typeface="Times New Roman" panose="02020603050405020304" pitchFamily="18" charset="0"/>
-            </a:endParaRPr>
           </a:p>
         </p:txBody>
       </p:sp>
@@ -10808,7 +10827,7 @@
           <p:nvPr/>
         </p:nvPicPr>
         <p:blipFill>
-          <a:blip r:embed="rId1"/>
+          <a:blip r:embed="rId3"/>
           <a:stretch>
             <a:fillRect/>
           </a:stretch>
@@ -10915,7 +10934,7 @@
           <p:nvPr/>
         </p:nvPicPr>
         <p:blipFill>
-          <a:blip r:embed="rId2"/>
+          <a:blip r:embed="rId4"/>
           <a:stretch>
             <a:fillRect/>
           </a:stretch>
@@ -10969,7 +10988,7 @@
           <p:nvPr/>
         </p:nvPicPr>
         <p:blipFill>
-          <a:blip r:embed="rId1"/>
+          <a:blip r:embed="rId3"/>
           <a:srcRect r="1340"/>
           <a:stretch>
             <a:fillRect/>
@@ -10999,7 +11018,7 @@
           <p:nvPr/>
         </p:nvPicPr>
         <p:blipFill>
-          <a:blip r:embed="rId2"/>
+          <a:blip r:embed="rId4"/>
           <a:stretch>
             <a:fillRect/>
           </a:stretch>
@@ -11347,13 +11366,6 @@
               </a:rPr>
               <a:t> the review form.</a:t>
             </a:r>
-            <a:endParaRPr lang="en-US" sz="2000" dirty="0">
-              <a:solidFill>
-                <a:schemeClr val="tx1"/>
-              </a:solidFill>
-              <a:latin typeface="Times New Roman" panose="02020603050405020304" pitchFamily="18" charset="0"/>
-              <a:cs typeface="Times New Roman" panose="02020603050405020304" pitchFamily="18" charset="0"/>
-            </a:endParaRPr>
           </a:p>
         </p:txBody>
       </p:sp>
@@ -11747,13 +11759,6 @@
               </a:rPr>
               <a:t>g) Evaluate the paper and provide your comments.</a:t>
             </a:r>
-            <a:endParaRPr lang="en-US" sz="2000" dirty="0">
-              <a:solidFill>
-                <a:schemeClr val="tx1"/>
-              </a:solidFill>
-              <a:latin typeface="Times New Roman" panose="02020603050405020304" pitchFamily="18" charset="0"/>
-              <a:cs typeface="Times New Roman" panose="02020603050405020304" pitchFamily="18" charset="0"/>
-            </a:endParaRPr>
           </a:p>
           <a:p>
             <a:pPr marL="342900">
@@ -11791,13 +11796,6 @@
               </a:rPr>
               <a:t>, such as relevance, originality, technical quality, clarity, significance, and overall recommendation.</a:t>
             </a:r>
-            <a:endParaRPr lang="en-US" sz="1600" dirty="0">
-              <a:solidFill>
-                <a:schemeClr val="tx1"/>
-              </a:solidFill>
-              <a:latin typeface="Times New Roman" panose="02020603050405020304" pitchFamily="18" charset="0"/>
-              <a:cs typeface="Times New Roman" panose="02020603050405020304" pitchFamily="18" charset="0"/>
-            </a:endParaRPr>
           </a:p>
           <a:p>
             <a:pPr marL="342900">
@@ -11815,13 +11813,6 @@
               </a:rPr>
               <a:t>Please provide constructive comments that can help the author(s) improve the paper.</a:t>
             </a:r>
-            <a:endParaRPr lang="en-US" sz="1600" dirty="0">
-              <a:solidFill>
-                <a:schemeClr val="tx1"/>
-              </a:solidFill>
-              <a:latin typeface="Times New Roman" panose="02020603050405020304" pitchFamily="18" charset="0"/>
-              <a:cs typeface="Times New Roman" panose="02020603050405020304" pitchFamily="18" charset="0"/>
-            </a:endParaRPr>
           </a:p>
           <a:p>
             <a:pPr marL="342900">
@@ -11876,7 +11867,7 @@
           <p:nvPr/>
         </p:nvPicPr>
         <p:blipFill>
-          <a:blip r:embed="rId1"/>
+          <a:blip r:embed="rId3"/>
           <a:stretch>
             <a:fillRect/>
           </a:stretch>
@@ -11902,7 +11893,7 @@
           <p:nvPr/>
         </p:nvPicPr>
         <p:blipFill>
-          <a:blip r:embed="rId1"/>
+          <a:blip r:embed="rId3"/>
           <a:stretch>
             <a:fillRect/>
           </a:stretch>
@@ -11928,7 +11919,7 @@
           <p:nvPr/>
         </p:nvPicPr>
         <p:blipFill>
-          <a:blip r:embed="rId1"/>
+          <a:blip r:embed="rId3"/>
           <a:stretch>
             <a:fillRect/>
           </a:stretch>
@@ -11954,7 +11945,7 @@
           <p:nvPr/>
         </p:nvPicPr>
         <p:blipFill>
-          <a:blip r:embed="rId2"/>
+          <a:blip r:embed="rId4"/>
           <a:stretch>
             <a:fillRect/>
           </a:stretch>
@@ -12219,7 +12210,7 @@
                 <a:latin typeface="Times New Roman" panose="02020603050405020304" pitchFamily="18" charset="0"/>
                 <a:cs typeface="Times New Roman" panose="02020603050405020304" pitchFamily="18" charset="0"/>
                 <a:sym typeface="+mn-ea"/>
-                <a:hlinkClick r:id="rId1" action="ppaction://hlinksldjump"/>
+                <a:hlinkClick r:id="rId3" action="ppaction://hlinksldjump"/>
               </a:rPr>
               <a:t>[</a:t>
             </a:r>
@@ -12228,7 +12219,7 @@
                 <a:latin typeface="Times New Roman" panose="02020603050405020304" pitchFamily="18" charset="0"/>
                 <a:cs typeface="Times New Roman" panose="02020603050405020304" pitchFamily="18" charset="0"/>
                 <a:sym typeface="+mn-ea"/>
-                <a:hlinkClick r:id="rId1" action="ppaction://hlinksldjump"/>
+                <a:hlinkClick r:id="rId3" action="ppaction://hlinksldjump"/>
               </a:rPr>
               <a:t>Slide 3</a:t>
             </a:r>
@@ -12237,7 +12228,7 @@
                 <a:latin typeface="Times New Roman" panose="02020603050405020304" pitchFamily="18" charset="0"/>
                 <a:cs typeface="Times New Roman" panose="02020603050405020304" pitchFamily="18" charset="0"/>
                 <a:sym typeface="+mn-ea"/>
-                <a:hlinkClick r:id="rId1" action="ppaction://hlinksldjump"/>
+                <a:hlinkClick r:id="rId3" action="ppaction://hlinksldjump"/>
               </a:rPr>
               <a:t>] </a:t>
             </a:r>
@@ -12264,25 +12255,16 @@
                 <a:latin typeface="Times New Roman" panose="02020603050405020304" pitchFamily="18" charset="0"/>
                 <a:cs typeface="Times New Roman" panose="02020603050405020304" pitchFamily="18" charset="0"/>
                 <a:sym typeface="+mn-ea"/>
-                <a:hlinkClick r:id="rId2" action="ppaction://hlinksldjump"/>
-              </a:rPr>
-              <a:t>[Slide</a:t>
-            </a:r>
-            <a:r>
-              <a:rPr lang="en-GB" sz="2000" dirty="0">
+                <a:hlinkClick r:id="rId4" action="ppaction://hlinksldjump"/>
+              </a:rPr>
+              <a:t>[Slide </a:t>
+            </a:r>
+            <a:r>
+              <a:rPr lang="en-US" altLang="zh-CN" sz="2000" dirty="0">
                 <a:latin typeface="Times New Roman" panose="02020603050405020304" pitchFamily="18" charset="0"/>
                 <a:cs typeface="Times New Roman" panose="02020603050405020304" pitchFamily="18" charset="0"/>
                 <a:sym typeface="+mn-ea"/>
-                <a:hlinkClick r:id="rId2" action="ppaction://hlinksldjump"/>
-              </a:rPr>
-              <a:t> </a:t>
-            </a:r>
-            <a:r>
-              <a:rPr lang="en-US" altLang="zh-CN" sz="2000" dirty="0">
-                <a:latin typeface="Times New Roman" panose="02020603050405020304" pitchFamily="18" charset="0"/>
-                <a:cs typeface="Times New Roman" panose="02020603050405020304" pitchFamily="18" charset="0"/>
-                <a:sym typeface="+mn-ea"/>
-                <a:hlinkClick r:id="rId2" action="ppaction://hlinksldjump"/>
+                <a:hlinkClick r:id="rId4" action="ppaction://hlinksldjump"/>
               </a:rPr>
               <a:t>11]</a:t>
             </a:r>
@@ -12333,7 +12315,7 @@
                 <a:latin typeface="Times New Roman" panose="02020603050405020304" pitchFamily="18" charset="0"/>
                 <a:cs typeface="Times New Roman" panose="02020603050405020304" pitchFamily="18" charset="0"/>
                 <a:sym typeface="+mn-ea"/>
-                <a:hlinkClick r:id="rId3" action="ppaction://hlinksldjump"/>
+                <a:hlinkClick r:id="rId5" action="ppaction://hlinksldjump"/>
               </a:rPr>
               <a:t>[Slide 12]</a:t>
             </a:r>
@@ -12363,7 +12345,7 @@
                 <a:latin typeface="Times New Roman" panose="02020603050405020304" pitchFamily="18" charset="0"/>
                 <a:cs typeface="Times New Roman" panose="02020603050405020304" pitchFamily="18" charset="0"/>
                 <a:sym typeface="+mn-ea"/>
-                <a:hlinkClick r:id="rId4" action="ppaction://hlinksldjump"/>
+                <a:hlinkClick r:id="rId6" action="ppaction://hlinksldjump"/>
               </a:rPr>
               <a:t>[Slide 21]</a:t>
             </a:r>
@@ -12390,7 +12372,7 @@
                 <a:latin typeface="Times New Roman" panose="02020603050405020304" pitchFamily="18" charset="0"/>
                 <a:cs typeface="Times New Roman" panose="02020603050405020304" pitchFamily="18" charset="0"/>
                 <a:sym typeface="+mn-ea"/>
-                <a:hlinkClick r:id="rId5" action="ppaction://hlinksldjump"/>
+                <a:hlinkClick r:id="rId7" action="ppaction://hlinksldjump"/>
               </a:rPr>
               <a:t>[Slide 22]</a:t>
             </a:r>
@@ -13036,13 +13018,6 @@
               </a:rPr>
               <a:t>h) Your review has been successfully submitted.</a:t>
             </a:r>
-            <a:endParaRPr lang="en-US" dirty="0">
-              <a:solidFill>
-                <a:schemeClr val="tx1"/>
-              </a:solidFill>
-              <a:latin typeface="Times New Roman" panose="02020603050405020304" pitchFamily="18" charset="0"/>
-              <a:cs typeface="Times New Roman" panose="02020603050405020304" pitchFamily="18" charset="0"/>
-            </a:endParaRPr>
           </a:p>
         </p:txBody>
       </p:sp>
@@ -13055,7 +13030,7 @@
           <p:nvPr/>
         </p:nvPicPr>
         <p:blipFill>
-          <a:blip r:embed="rId1"/>
+          <a:blip r:embed="rId3"/>
           <a:stretch>
             <a:fillRect/>
           </a:stretch>
@@ -13225,7 +13200,7 @@
                 </a:solidFill>
                 <a:latin typeface="Times New Roman" panose="02020603050405020304" pitchFamily="18" charset="0"/>
                 <a:cs typeface="Times New Roman" panose="02020603050405020304" pitchFamily="18" charset="0"/>
-                <a:hlinkClick r:id="rId1"/>
+                <a:hlinkClick r:id="rId3"/>
               </a:rPr>
               <a:t>uv.conf.committee@universal-village.org</a:t>
             </a:r>
@@ -13239,13 +13214,6 @@
               </a:rPr>
               <a:t>. We will send the assigned paper and an offline review form to you by email.</a:t>
             </a:r>
-            <a:endParaRPr lang="en-US" sz="2000" dirty="0">
-              <a:solidFill>
-                <a:schemeClr val="dk1"/>
-              </a:solidFill>
-              <a:latin typeface="Times New Roman" panose="02020603050405020304" pitchFamily="18" charset="0"/>
-              <a:cs typeface="Times New Roman" panose="02020603050405020304" pitchFamily="18" charset="0"/>
-            </a:endParaRPr>
           </a:p>
           <a:p>
             <a:pPr marL="285750" indent="-285750"/>
@@ -13266,7 +13234,7 @@
                 </a:solidFill>
                 <a:latin typeface="Times New Roman" panose="02020603050405020304" pitchFamily="18" charset="0"/>
                 <a:cs typeface="Times New Roman" panose="02020603050405020304" pitchFamily="18" charset="0"/>
-                <a:hlinkClick r:id="rId1"/>
+                <a:hlinkClick r:id="rId3"/>
               </a:rPr>
               <a:t>uv.conf.committee@universal-village.org</a:t>
             </a:r>
@@ -13280,13 +13248,6 @@
               </a:rPr>
               <a:t>. </a:t>
             </a:r>
-            <a:endParaRPr lang="en-US" sz="2000" dirty="0">
-              <a:solidFill>
-                <a:schemeClr val="dk1"/>
-              </a:solidFill>
-              <a:latin typeface="Times New Roman" panose="02020603050405020304" pitchFamily="18" charset="0"/>
-              <a:cs typeface="Times New Roman" panose="02020603050405020304" pitchFamily="18" charset="0"/>
-            </a:endParaRPr>
           </a:p>
         </p:txBody>
       </p:sp>
@@ -13358,13 +13319,6 @@
               </a:rPr>
               <a:t>3. Check or Edit a Submitted Review-1</a:t>
             </a:r>
-            <a:endParaRPr lang="en-US" b="1" dirty="0">
-              <a:solidFill>
-                <a:srgbClr val="980000"/>
-              </a:solidFill>
-              <a:latin typeface="Times New Roman" panose="02020603050405020304" pitchFamily="18" charset="0"/>
-              <a:cs typeface="Times New Roman" panose="02020603050405020304" pitchFamily="18" charset="0"/>
-            </a:endParaRPr>
           </a:p>
         </p:txBody>
       </p:sp>
@@ -13432,13 +13386,6 @@
               </a:rPr>
               <a:t> using the account you used to submit the review.</a:t>
             </a:r>
-            <a:endParaRPr lang="en-US" sz="2000" dirty="0">
-              <a:solidFill>
-                <a:schemeClr val="tx1"/>
-              </a:solidFill>
-              <a:latin typeface="Times New Roman" panose="02020603050405020304" pitchFamily="18" charset="0"/>
-              <a:cs typeface="Times New Roman" panose="02020603050405020304" pitchFamily="18" charset="0"/>
-            </a:endParaRPr>
           </a:p>
           <a:p>
             <a:pPr marL="0" lvl="0" indent="0" algn="l" rtl="0">
@@ -13460,13 +13407,6 @@
               </a:rPr>
               <a:t>*If your review was submitted through the offline review form, please contact your session chair or the UV2026 Organizing Committee if you need to make changes.</a:t>
             </a:r>
-            <a:endParaRPr lang="en-US" sz="1600" dirty="0">
-              <a:solidFill>
-                <a:schemeClr val="tx1"/>
-              </a:solidFill>
-              <a:latin typeface="Times New Roman" panose="02020603050405020304" pitchFamily="18" charset="0"/>
-              <a:cs typeface="Times New Roman" panose="02020603050405020304" pitchFamily="18" charset="0"/>
-            </a:endParaRPr>
           </a:p>
         </p:txBody>
       </p:sp>
@@ -13477,7 +13417,7 @@
           <p:nvPr/>
         </p:nvPicPr>
         <p:blipFill>
-          <a:blip r:embed="rId1"/>
+          <a:blip r:embed="rId3"/>
           <a:stretch>
             <a:fillRect/>
           </a:stretch>
@@ -13621,13 +13561,6 @@
               </a:rPr>
               <a:t>” to access your review page.</a:t>
             </a:r>
-            <a:endParaRPr lang="en-US" dirty="0">
-              <a:solidFill>
-                <a:schemeClr val="tx1"/>
-              </a:solidFill>
-              <a:latin typeface="Times New Roman" panose="02020603050405020304" pitchFamily="18" charset="0"/>
-              <a:cs typeface="Times New Roman" panose="02020603050405020304" pitchFamily="18" charset="0"/>
-            </a:endParaRPr>
           </a:p>
         </p:txBody>
       </p:sp>
@@ -13640,7 +13573,7 @@
           <p:nvPr/>
         </p:nvPicPr>
         <p:blipFill>
-          <a:blip r:embed="rId1"/>
+          <a:blip r:embed="rId3"/>
           <a:stretch>
             <a:fillRect/>
           </a:stretch>
@@ -13703,13 +13636,6 @@
               </a:rPr>
               <a:t>3. Check or Edit a Submitted Review-2</a:t>
             </a:r>
-            <a:endParaRPr lang="en-US" b="1" dirty="0">
-              <a:solidFill>
-                <a:srgbClr val="980000"/>
-              </a:solidFill>
-              <a:latin typeface="Times New Roman" panose="02020603050405020304" pitchFamily="18" charset="0"/>
-              <a:cs typeface="Times New Roman" panose="02020603050405020304" pitchFamily="18" charset="0"/>
-            </a:endParaRPr>
           </a:p>
         </p:txBody>
       </p:sp>
@@ -13782,13 +13708,6 @@
               </a:rPr>
               <a:t>c) Find the relevant paper and click the view icon          to open the submitted review.</a:t>
             </a:r>
-            <a:endParaRPr lang="en-US" sz="2000" dirty="0">
-              <a:solidFill>
-                <a:schemeClr val="dk1"/>
-              </a:solidFill>
-              <a:latin typeface="Times New Roman" panose="02020603050405020304" pitchFamily="18" charset="0"/>
-              <a:cs typeface="Times New Roman" panose="02020603050405020304" pitchFamily="18" charset="0"/>
-            </a:endParaRPr>
           </a:p>
         </p:txBody>
       </p:sp>
@@ -13799,7 +13718,7 @@
           <p:nvPr/>
         </p:nvPicPr>
         <p:blipFill>
-          <a:blip r:embed="rId1"/>
+          <a:blip r:embed="rId3"/>
           <a:srcRect b="20451"/>
           <a:stretch>
             <a:fillRect/>
@@ -13830,7 +13749,7 @@
           <p:nvPr/>
         </p:nvPicPr>
         <p:blipFill>
-          <a:blip r:embed="rId2"/>
+          <a:blip r:embed="rId4"/>
           <a:stretch>
             <a:fillRect/>
           </a:stretch>
@@ -13893,13 +13812,6 @@
               </a:rPr>
               <a:t>3. Check or Edit a Submitted Review-3</a:t>
             </a:r>
-            <a:endParaRPr lang="en-US" b="1" dirty="0">
-              <a:solidFill>
-                <a:srgbClr val="980000"/>
-              </a:solidFill>
-              <a:latin typeface="Times New Roman" panose="02020603050405020304" pitchFamily="18" charset="0"/>
-              <a:cs typeface="Times New Roman" panose="02020603050405020304" pitchFamily="18" charset="0"/>
-            </a:endParaRPr>
           </a:p>
         </p:txBody>
       </p:sp>
@@ -13972,13 +13884,6 @@
               </a:rPr>
               <a:t>d) Check or Edit a Submitted Review</a:t>
             </a:r>
-            <a:endParaRPr lang="en-US" sz="2200" dirty="0">
-              <a:solidFill>
-                <a:schemeClr val="tx1"/>
-              </a:solidFill>
-              <a:latin typeface="Times New Roman" panose="02020603050405020304" pitchFamily="18" charset="0"/>
-              <a:cs typeface="Times New Roman" panose="02020603050405020304" pitchFamily="18" charset="0"/>
-            </a:endParaRPr>
           </a:p>
           <a:p>
             <a:pPr marL="285750" indent="-285750">
@@ -13996,13 +13901,6 @@
               </a:rPr>
               <a:t>On this page, you can view the summary of the submitted review. To check the full review details, click the review title, such as “Review 1”.</a:t>
             </a:r>
-            <a:endParaRPr lang="en-US" sz="1700" dirty="0">
-              <a:solidFill>
-                <a:schemeClr val="tx1"/>
-              </a:solidFill>
-              <a:latin typeface="Times New Roman" panose="02020603050405020304" pitchFamily="18" charset="0"/>
-              <a:cs typeface="Times New Roman" panose="02020603050405020304" pitchFamily="18" charset="0"/>
-            </a:endParaRPr>
           </a:p>
           <a:p>
             <a:pPr marL="285750" indent="-285750">
@@ -14339,13 +14237,6 @@
               </a:rPr>
               <a:t>3. Check or Edit a Submitted Review-4</a:t>
             </a:r>
-            <a:endParaRPr lang="en-US" b="1" dirty="0">
-              <a:solidFill>
-                <a:srgbClr val="980000"/>
-              </a:solidFill>
-              <a:latin typeface="Times New Roman" panose="02020603050405020304" pitchFamily="18" charset="0"/>
-              <a:cs typeface="Times New Roman" panose="02020603050405020304" pitchFamily="18" charset="0"/>
-            </a:endParaRPr>
           </a:p>
         </p:txBody>
       </p:sp>
@@ -14358,7 +14249,7 @@
           <p:nvPr/>
         </p:nvPicPr>
         <p:blipFill>
-          <a:blip r:embed="rId1"/>
+          <a:blip r:embed="rId3"/>
           <a:stretch>
             <a:fillRect/>
           </a:stretch>
@@ -14433,10 +14324,6 @@
               </a:rPr>
               <a:t>For any question-related inquiries:</a:t>
             </a:r>
-            <a:endParaRPr lang="en-US" altLang="zh-CN" sz="3200" b="1" dirty="0">
-              <a:latin typeface="Times New Roman" panose="02020603050405020304" pitchFamily="18" charset="0"/>
-              <a:cs typeface="Times New Roman" panose="02020603050405020304" pitchFamily="18" charset="0"/>
-            </a:endParaRPr>
           </a:p>
           <a:p>
             <a:pPr marL="114300" indent="0" algn="ctr">
@@ -14446,7 +14333,7 @@
               <a:rPr lang="en-US" altLang="zh-CN" sz="3200" b="1" u="sng" dirty="0">
                 <a:latin typeface="Times New Roman" panose="02020603050405020304" pitchFamily="18" charset="0"/>
                 <a:cs typeface="Times New Roman" panose="02020603050405020304" pitchFamily="18" charset="0"/>
-                <a:hlinkClick r:id="rId1"/>
+                <a:hlinkClick r:id="rId2"/>
               </a:rPr>
               <a:t>uv2026.conf@universal-village.org</a:t>
             </a:r>
@@ -14759,13 +14646,6 @@
               </a:rPr>
               <a:t>Contact Information Account Creation</a:t>
             </a:r>
-            <a:endParaRPr lang="en-US" altLang="zh-CN" sz="2700" b="1" dirty="0">
-              <a:solidFill>
-                <a:srgbClr val="980000"/>
-              </a:solidFill>
-              <a:latin typeface="Times New Roman" panose="02020603050405020304" pitchFamily="18" charset="0"/>
-              <a:cs typeface="Times New Roman" panose="02020603050405020304" pitchFamily="18" charset="0"/>
-            </a:endParaRPr>
           </a:p>
         </p:txBody>
       </p:sp>
@@ -14864,13 +14744,6 @@
               </a:rPr>
               <a:t> Account-1</a:t>
             </a:r>
-            <a:endParaRPr lang="en-US" altLang="zh-CN" sz="3110" b="1" dirty="0">
-              <a:solidFill>
-                <a:srgbClr val="980000"/>
-              </a:solidFill>
-              <a:latin typeface="Times New Roman" panose="02020603050405020304" pitchFamily="18" charset="0"/>
-              <a:cs typeface="Times New Roman" panose="02020603050405020304" pitchFamily="18" charset="0"/>
-            </a:endParaRPr>
           </a:p>
         </p:txBody>
       </p:sp>
@@ -14945,13 +14818,6 @@
               </a:rPr>
               <a:t> </a:t>
             </a:r>
-            <a:endParaRPr lang="en-GB" sz="1600" dirty="0">
-              <a:solidFill>
-                <a:schemeClr val="dk1"/>
-              </a:solidFill>
-              <a:latin typeface="Times New Roman" panose="02020603050405020304" pitchFamily="18" charset="0"/>
-              <a:cs typeface="Times New Roman" panose="02020603050405020304" pitchFamily="18" charset="0"/>
-            </a:endParaRPr>
           </a:p>
           <a:p>
             <a:pPr marL="1346200" lvl="2" indent="-285750" algn="l" rtl="0">
@@ -14996,7 +14862,7 @@
                 </a:solidFill>
                 <a:latin typeface="Times New Roman" panose="02020603050405020304" pitchFamily="18" charset="0"/>
                 <a:cs typeface="Times New Roman" panose="02020603050405020304" pitchFamily="18" charset="0"/>
-                <a:hlinkClick r:id="rId1" action="ppaction://hlinkfile"/>
+                <a:hlinkClick r:id="rId3" action="ppaction://hlinkfile"/>
               </a:rPr>
               <a:t>Log in</a:t>
             </a:r>
@@ -15187,7 +15053,7 @@
           <p:nvPr/>
         </p:nvPicPr>
         <p:blipFill>
-          <a:blip r:embed="rId2"/>
+          <a:blip r:embed="rId4"/>
           <a:stretch>
             <a:fillRect/>
           </a:stretch>
@@ -15310,13 +15176,6 @@
               </a:rPr>
               <a:t> (reCAPTCHA) as required.</a:t>
             </a:r>
-            <a:endParaRPr lang="en-US" altLang="zh-CN" sz="1600">
-              <a:solidFill>
-                <a:schemeClr val="dk1"/>
-              </a:solidFill>
-              <a:latin typeface="Times New Roman" panose="02020603050405020304" pitchFamily="18" charset="0"/>
-              <a:cs typeface="Times New Roman" panose="02020603050405020304" pitchFamily="18" charset="0"/>
-            </a:endParaRPr>
           </a:p>
           <a:p>
             <a:pPr marL="342900" lvl="0" algn="l" rtl="0">
@@ -15341,7 +15200,7 @@
           <p:nvPr/>
         </p:nvPicPr>
         <p:blipFill>
-          <a:blip r:embed="rId1"/>
+          <a:blip r:embed="rId3"/>
           <a:stretch>
             <a:fillRect/>
           </a:stretch>
@@ -15683,13 +15542,6 @@
               </a:rPr>
               <a:t> Account-2</a:t>
             </a:r>
-            <a:endParaRPr lang="en-US" altLang="zh-CN" b="1" dirty="0">
-              <a:solidFill>
-                <a:srgbClr val="980000"/>
-              </a:solidFill>
-              <a:latin typeface="Times New Roman" panose="02020603050405020304" pitchFamily="18" charset="0"/>
-              <a:cs typeface="Times New Roman" panose="02020603050405020304" pitchFamily="18" charset="0"/>
-            </a:endParaRPr>
           </a:p>
         </p:txBody>
       </p:sp>
@@ -15785,13 +15637,6 @@
               </a:rPr>
               <a:t>.</a:t>
             </a:r>
-            <a:endParaRPr lang="en-US" altLang="en-GB" sz="1600" dirty="0">
-              <a:solidFill>
-                <a:schemeClr val="dk1"/>
-              </a:solidFill>
-              <a:latin typeface="Times New Roman" panose="02020603050405020304" pitchFamily="18" charset="0"/>
-              <a:cs typeface="Times New Roman" panose="02020603050405020304" pitchFamily="18" charset="0"/>
-            </a:endParaRPr>
           </a:p>
         </p:txBody>
       </p:sp>
@@ -15802,7 +15647,7 @@
           <p:nvPr/>
         </p:nvPicPr>
         <p:blipFill>
-          <a:blip r:embed="rId1"/>
+          <a:blip r:embed="rId3"/>
           <a:stretch>
             <a:fillRect/>
           </a:stretch>
@@ -15898,13 +15743,6 @@
               </a:rPr>
               <a:t> Account-3</a:t>
             </a:r>
-            <a:endParaRPr lang="en-US" altLang="zh-CN" sz="3110" b="1" dirty="0">
-              <a:solidFill>
-                <a:srgbClr val="980000"/>
-              </a:solidFill>
-              <a:latin typeface="Times New Roman" panose="02020603050405020304" pitchFamily="18" charset="0"/>
-              <a:cs typeface="Times New Roman" panose="02020603050405020304" pitchFamily="18" charset="0"/>
-            </a:endParaRPr>
           </a:p>
         </p:txBody>
       </p:sp>
@@ -16009,14 +15847,6 @@
               </a:rPr>
               <a:t>f)  Check your email inbox for a verification message from EasyChair.</a:t>
             </a:r>
-            <a:endParaRPr lang="en-US" altLang="zh-CN" sz="1800" dirty="0">
-              <a:solidFill>
-                <a:schemeClr val="dk1"/>
-              </a:solidFill>
-              <a:latin typeface="Times New Roman" panose="02020603050405020304" pitchFamily="18" charset="0"/>
-              <a:cs typeface="Times New Roman" panose="02020603050405020304" pitchFamily="18" charset="0"/>
-              <a:sym typeface="+mn-ea"/>
-            </a:endParaRPr>
           </a:p>
           <a:p>
             <a:pPr marL="457200" lvl="1" indent="0" algn="l">
@@ -16059,14 +15889,6 @@
               </a:rPr>
               <a:t>g)  Enter the verification code provided in the email.</a:t>
             </a:r>
-            <a:endParaRPr lang="en-US" altLang="zh-CN" sz="1800" dirty="0">
-              <a:solidFill>
-                <a:schemeClr val="dk1"/>
-              </a:solidFill>
-              <a:latin typeface="Times New Roman" panose="02020603050405020304" pitchFamily="18" charset="0"/>
-              <a:cs typeface="Times New Roman" panose="02020603050405020304" pitchFamily="18" charset="0"/>
-              <a:sym typeface="+mn-ea"/>
-            </a:endParaRPr>
           </a:p>
           <a:p>
             <a:pPr marL="457200" lvl="1" indent="0" algn="l">
@@ -16209,7 +16031,7 @@
           <p:nvPr/>
         </p:nvPicPr>
         <p:blipFill>
-          <a:blip r:embed="rId1"/>
+          <a:blip r:embed="rId3"/>
           <a:stretch>
             <a:fillRect/>
           </a:stretch>
@@ -16305,13 +16127,6 @@
               </a:rPr>
               <a:t> Account-4</a:t>
             </a:r>
-            <a:endParaRPr lang="en-US" altLang="zh-CN" sz="3110" b="1" dirty="0">
-              <a:solidFill>
-                <a:srgbClr val="980000"/>
-              </a:solidFill>
-              <a:latin typeface="Times New Roman" panose="02020603050405020304" pitchFamily="18" charset="0"/>
-              <a:cs typeface="Times New Roman" panose="02020603050405020304" pitchFamily="18" charset="0"/>
-            </a:endParaRPr>
           </a:p>
         </p:txBody>
       </p:sp>
@@ -16322,7 +16137,7 @@
           <p:nvPr/>
         </p:nvPicPr>
         <p:blipFill>
-          <a:blip r:embed="rId2"/>
+          <a:blip r:embed="rId4"/>
           <a:stretch>
             <a:fillRect/>
           </a:stretch>
@@ -16506,7 +16321,7 @@
           <p:nvPr/>
         </p:nvPicPr>
         <p:blipFill>
-          <a:blip r:embed="rId1"/>
+          <a:blip r:embed="rId3"/>
           <a:stretch>
             <a:fillRect/>
           </a:stretch>
@@ -16605,14 +16420,6 @@
               </a:rPr>
               <a:t> Account-5</a:t>
             </a:r>
-            <a:endParaRPr lang="en-US" altLang="zh-CN" sz="3110" b="1" dirty="0">
-              <a:solidFill>
-                <a:srgbClr val="980000"/>
-              </a:solidFill>
-              <a:latin typeface="Times New Roman" panose="02020603050405020304" pitchFamily="18" charset="0"/>
-              <a:ea typeface="SimSun" panose="02010600030101010101" pitchFamily="2" charset="-122"/>
-              <a:cs typeface="Times New Roman" panose="02020603050405020304" pitchFamily="18" charset="0"/>
-            </a:endParaRPr>
           </a:p>
         </p:txBody>
       </p:sp>
@@ -16702,13 +16509,6 @@
               </a:rPr>
               <a:t> </a:t>
             </a:r>
-            <a:endParaRPr lang="en-GB" sz="1600" dirty="0">
-              <a:solidFill>
-                <a:schemeClr val="dk1"/>
-              </a:solidFill>
-              <a:latin typeface="Times New Roman" panose="02020603050405020304" pitchFamily="18" charset="0"/>
-              <a:cs typeface="Times New Roman" panose="02020603050405020304" pitchFamily="18" charset="0"/>
-            </a:endParaRPr>
           </a:p>
           <a:p>
             <a:pPr marL="742950" lvl="1" indent="-285750" algn="l" rtl="0">
@@ -16729,7 +16529,7 @@
                 </a:solidFill>
                 <a:latin typeface="Times New Roman" panose="02020603050405020304" pitchFamily="18" charset="0"/>
                 <a:cs typeface="Times New Roman" panose="02020603050405020304" pitchFamily="18" charset="0"/>
-                <a:hlinkClick r:id="rId1" action="ppaction://hlinkfile"/>
+                <a:hlinkClick r:id="rId3" action="ppaction://hlinkfile"/>
               </a:rPr>
               <a:t>Log in</a:t>
             </a:r>
@@ -16809,7 +16609,7 @@
           <p:nvPr/>
         </p:nvPicPr>
         <p:blipFill>
-          <a:blip r:embed="rId2"/>
+          <a:blip r:embed="rId4"/>
           <a:stretch>
             <a:fillRect/>
           </a:stretch>
@@ -16905,13 +16705,6 @@
               </a:rPr>
               <a:t> Account-6</a:t>
             </a:r>
-            <a:endParaRPr lang="en-US" altLang="zh-CN" sz="3110" b="1" dirty="0">
-              <a:solidFill>
-                <a:srgbClr val="980000"/>
-              </a:solidFill>
-              <a:latin typeface="Times New Roman" panose="02020603050405020304" pitchFamily="18" charset="0"/>
-              <a:cs typeface="Times New Roman" panose="02020603050405020304" pitchFamily="18" charset="0"/>
-            </a:endParaRPr>
           </a:p>
         </p:txBody>
       </p:sp>
@@ -17017,7 +16810,7 @@
                 <a:solidFill>
                   <a:srgbClr val="00B050"/>
                 </a:solidFill>
-                <a:hlinkClick r:id="rId1"/>
+                <a:hlinkClick r:id="rId3"/>
               </a:rPr>
               <a:t>https://easychair.org/conferences/?conf=ieeeUV2026</a:t>
             </a:r>
@@ -17045,11 +16838,6 @@
               </a:rPr>
               <a:t> </a:t>
             </a:r>
-            <a:endParaRPr lang="en-US" sz="1800" i="1" dirty="0">
-              <a:solidFill>
-                <a:srgbClr val="00B050"/>
-              </a:solidFill>
-            </a:endParaRPr>
           </a:p>
           <a:p>
             <a:pPr marL="558800" lvl="1" indent="0">
@@ -17288,7 +17076,7 @@
             <p:nvPr/>
           </p:nvPicPr>
           <p:blipFill>
-            <a:blip r:embed="rId2"/>
+            <a:blip r:embed="rId4"/>
             <a:stretch>
               <a:fillRect/>
             </a:stretch>
@@ -17363,10 +17151,10 @@
             <p:nvPr/>
           </p:nvPicPr>
           <p:blipFill>
-            <a:blip r:embed="rId3">
+            <a:blip r:embed="rId5">
               <a:extLst>
                 <a:ext uri="{96DAC541-7B7A-43D3-8B79-37D633B846F1}">
-                  <asvg:svgBlip xmlns:asvg="http://schemas.microsoft.com/office/drawing/2016/SVG/main" r:embed="rId4"/>
+                  <asvg:svgBlip xmlns:asvg="http://schemas.microsoft.com/office/drawing/2016/SVG/main" r:embed="rId6"/>
                 </a:ext>
               </a:extLst>
             </a:blip>
@@ -17704,13 +17492,6 @@
               </a:rPr>
               <a:t> Account-7</a:t>
             </a:r>
-            <a:endParaRPr lang="en-US" altLang="zh-CN" sz="3110" b="1" dirty="0">
-              <a:solidFill>
-                <a:srgbClr val="980000"/>
-              </a:solidFill>
-              <a:latin typeface="Times New Roman" panose="02020603050405020304" pitchFamily="18" charset="0"/>
-              <a:cs typeface="Times New Roman" panose="02020603050405020304" pitchFamily="18" charset="0"/>
-            </a:endParaRPr>
           </a:p>
         </p:txBody>
       </p:sp>
@@ -17998,6 +17779,8 @@
       </a:bgFillStyleLst>
     </a:fmtScheme>
   </a:themeElements>
+  <a:objectDefaults/>
+  <a:extraClrSchemeLst/>
   <a:extLst>
     <a:ext uri="{05A4C25C-085E-4340-85A3-A5531E510DB2}">
       <thm15:themeFamily xmlns:thm15="http://schemas.microsoft.com/office/thememl/2012/main" name="Office Theme" id="{62F939B6-93AF-4DB8-9C6B-D6C7DFDC589F}" vid="{4A3C46E8-61CC-4603-A589-7422A47A8E4A}"/>
@@ -18282,6 +18065,8 @@
       </a:bgFillStyleLst>
     </a:fmtScheme>
   </a:themeElements>
+  <a:objectDefaults/>
+  <a:extraClrSchemeLst/>
   <a:extLst>
     <a:ext uri="{05A4C25C-085E-4340-85A3-A5531E510DB2}">
       <thm15:themeFamily xmlns:thm15="http://schemas.microsoft.com/office/thememl/2012/main" name="Office Theme" id="{62F939B6-93AF-4DB8-9C6B-D6C7DFDC589F}" vid="{4A3C46E8-61CC-4603-A589-7422A47A8E4A}"/>
@@ -18541,6 +18326,8 @@
       </a:bgFillStyleLst>
     </a:fmtScheme>
   </a:themeElements>
+  <a:objectDefaults/>
+  <a:extraClrSchemeLst/>
   <a:extLst>
     <a:ext uri="{05A4C25C-085E-4340-85A3-A5531E510DB2}">
       <thm15:themeFamily xmlns:thm15="http://schemas.microsoft.com/office/thememl/2012/main" name="Office Theme" id="{62F939B6-93AF-4DB8-9C6B-D6C7DFDC589F}" vid="{4A3C46E8-61CC-4603-A589-7422A47A8E4A}"/>

</xml_diff>